<commit_message>
business card: bigger logo on front
Co-Authored-By: Claude Sonnet 4.6 <noreply@anthropic.com>
</commit_message>
<xml_diff>
--- a/business-card-madjou-balde.pptx
+++ b/business-card-madjou-balde.pptx
@@ -3107,8 +3107,8 @@
         </p:nvCxnSpPr>
         <p:spPr>
           <a:xfrm>
-            <a:off x="201168" y="283779"/>
-            <a:ext cx="321616" cy="0"/>
+            <a:off x="201168" y="334228"/>
+            <a:ext cx="482424" cy="0"/>
           </a:xfrm>
           <a:prstGeom prst="line">
             <a:avLst/>
@@ -3142,8 +3142,8 @@
         </p:nvCxnSpPr>
         <p:spPr>
           <a:xfrm>
-            <a:off x="201168" y="409903"/>
-            <a:ext cx="321616" cy="0"/>
+            <a:off x="201168" y="523415"/>
+            <a:ext cx="482424" cy="0"/>
           </a:xfrm>
           <a:prstGeom prst="line">
             <a:avLst/>
@@ -3177,8 +3177,8 @@
         </p:nvCxnSpPr>
         <p:spPr>
           <a:xfrm>
-            <a:off x="201168" y="283779"/>
-            <a:ext cx="0" cy="126124"/>
+            <a:off x="201168" y="334228"/>
+            <a:ext cx="0" cy="189187"/>
           </a:xfrm>
           <a:prstGeom prst="line">
             <a:avLst/>
@@ -3212,8 +3212,8 @@
         </p:nvCxnSpPr>
         <p:spPr>
           <a:xfrm>
-            <a:off x="522784" y="283779"/>
-            <a:ext cx="0" cy="126124"/>
+            <a:off x="683592" y="334228"/>
+            <a:ext cx="0" cy="189187"/>
           </a:xfrm>
           <a:prstGeom prst="line">
             <a:avLst/>
@@ -3247,8 +3247,8 @@
         </p:nvCxnSpPr>
         <p:spPr>
           <a:xfrm>
-            <a:off x="220086" y="302697"/>
-            <a:ext cx="63062" cy="0"/>
+            <a:off x="229545" y="362606"/>
+            <a:ext cx="94594" cy="0"/>
           </a:xfrm>
           <a:prstGeom prst="line">
             <a:avLst/>
@@ -3282,8 +3282,8 @@
         </p:nvCxnSpPr>
         <p:spPr>
           <a:xfrm>
-            <a:off x="251617" y="302697"/>
-            <a:ext cx="0" cy="94594"/>
+            <a:off x="276842" y="362606"/>
+            <a:ext cx="0" cy="141890"/>
           </a:xfrm>
           <a:prstGeom prst="line">
             <a:avLst/>
@@ -3317,8 +3317,8 @@
         </p:nvCxnSpPr>
         <p:spPr>
           <a:xfrm flipH="1">
-            <a:off x="295761" y="302697"/>
-            <a:ext cx="63062" cy="0"/>
+            <a:off x="343057" y="362606"/>
+            <a:ext cx="94593" cy="0"/>
           </a:xfrm>
           <a:prstGeom prst="line">
             <a:avLst/>
@@ -3352,8 +3352,8 @@
         </p:nvCxnSpPr>
         <p:spPr>
           <a:xfrm>
-            <a:off x="295761" y="302697"/>
-            <a:ext cx="0" cy="94594"/>
+            <a:off x="343057" y="362606"/>
+            <a:ext cx="0" cy="141890"/>
           </a:xfrm>
           <a:prstGeom prst="line">
             <a:avLst/>
@@ -3387,8 +3387,8 @@
         </p:nvCxnSpPr>
         <p:spPr>
           <a:xfrm>
-            <a:off x="295761" y="397291"/>
-            <a:ext cx="63062" cy="0"/>
+            <a:off x="343057" y="504496"/>
+            <a:ext cx="94593" cy="0"/>
           </a:xfrm>
           <a:prstGeom prst="line">
             <a:avLst/>
@@ -3422,8 +3422,8 @@
         </p:nvCxnSpPr>
         <p:spPr>
           <a:xfrm>
-            <a:off x="295761" y="346841"/>
-            <a:ext cx="50449" cy="0"/>
+            <a:off x="343057" y="428822"/>
+            <a:ext cx="75675" cy="0"/>
           </a:xfrm>
           <a:prstGeom prst="line">
             <a:avLst/>
@@ -3457,8 +3457,8 @@
         </p:nvCxnSpPr>
         <p:spPr>
           <a:xfrm flipH="1">
-            <a:off x="371435" y="302697"/>
-            <a:ext cx="63062" cy="0"/>
+            <a:off x="456569" y="362606"/>
+            <a:ext cx="94593" cy="0"/>
           </a:xfrm>
           <a:prstGeom prst="line">
             <a:avLst/>
@@ -3492,8 +3492,8 @@
         </p:nvCxnSpPr>
         <p:spPr>
           <a:xfrm>
-            <a:off x="371435" y="302697"/>
-            <a:ext cx="0" cy="94594"/>
+            <a:off x="456569" y="362606"/>
+            <a:ext cx="0" cy="141890"/>
           </a:xfrm>
           <a:prstGeom prst="line">
             <a:avLst/>
@@ -3527,8 +3527,8 @@
         </p:nvCxnSpPr>
         <p:spPr>
           <a:xfrm>
-            <a:off x="371435" y="397291"/>
-            <a:ext cx="63062" cy="0"/>
+            <a:off x="456569" y="504496"/>
+            <a:ext cx="94593" cy="0"/>
           </a:xfrm>
           <a:prstGeom prst="line">
             <a:avLst/>
@@ -3562,8 +3562,8 @@
         </p:nvCxnSpPr>
         <p:spPr>
           <a:xfrm>
-            <a:off x="447110" y="302697"/>
-            <a:ext cx="0" cy="94594"/>
+            <a:off x="570081" y="362606"/>
+            <a:ext cx="0" cy="141890"/>
           </a:xfrm>
           <a:prstGeom prst="line">
             <a:avLst/>
@@ -3597,8 +3597,8 @@
         </p:nvCxnSpPr>
         <p:spPr>
           <a:xfrm>
-            <a:off x="510172" y="302697"/>
-            <a:ext cx="0" cy="94594"/>
+            <a:off x="664674" y="362606"/>
+            <a:ext cx="0" cy="141890"/>
           </a:xfrm>
           <a:prstGeom prst="line">
             <a:avLst/>
@@ -3632,8 +3632,8 @@
         </p:nvCxnSpPr>
         <p:spPr>
           <a:xfrm>
-            <a:off x="447110" y="346841"/>
-            <a:ext cx="63062" cy="0"/>
+            <a:off x="570081" y="428822"/>
+            <a:ext cx="94593" cy="0"/>
           </a:xfrm>
           <a:prstGeom prst="line">
             <a:avLst/>
@@ -3667,8 +3667,8 @@
         </p:nvCxnSpPr>
         <p:spPr>
           <a:xfrm flipV="1">
-            <a:off x="548009" y="302697"/>
-            <a:ext cx="31531" cy="94594"/>
+            <a:off x="721430" y="362606"/>
+            <a:ext cx="47296" cy="141890"/>
           </a:xfrm>
           <a:prstGeom prst="line">
             <a:avLst/>
@@ -3702,8 +3702,8 @@
         </p:nvCxnSpPr>
         <p:spPr>
           <a:xfrm>
-            <a:off x="579540" y="302697"/>
-            <a:ext cx="31531" cy="94594"/>
+            <a:off x="768726" y="362606"/>
+            <a:ext cx="47297" cy="141890"/>
           </a:xfrm>
           <a:prstGeom prst="line">
             <a:avLst/>
@@ -3737,8 +3737,8 @@
         </p:nvCxnSpPr>
         <p:spPr>
           <a:xfrm>
-            <a:off x="560621" y="353147"/>
-            <a:ext cx="37838" cy="0"/>
+            <a:off x="740348" y="438281"/>
+            <a:ext cx="56756" cy="0"/>
           </a:xfrm>
           <a:prstGeom prst="line">
             <a:avLst/>
@@ -3772,8 +3772,8 @@
         </p:nvCxnSpPr>
         <p:spPr>
           <a:xfrm flipH="1">
-            <a:off x="623683" y="302697"/>
-            <a:ext cx="63062" cy="0"/>
+            <a:off x="834941" y="362606"/>
+            <a:ext cx="94593" cy="0"/>
           </a:xfrm>
           <a:prstGeom prst="line">
             <a:avLst/>
@@ -3807,8 +3807,8 @@
         </p:nvCxnSpPr>
         <p:spPr>
           <a:xfrm>
-            <a:off x="623683" y="302697"/>
-            <a:ext cx="0" cy="94594"/>
+            <a:off x="834941" y="362606"/>
+            <a:ext cx="0" cy="141890"/>
           </a:xfrm>
           <a:prstGeom prst="line">
             <a:avLst/>
@@ -3842,8 +3842,8 @@
         </p:nvCxnSpPr>
         <p:spPr>
           <a:xfrm>
-            <a:off x="623683" y="346841"/>
-            <a:ext cx="50450" cy="0"/>
+            <a:off x="834941" y="428822"/>
+            <a:ext cx="75675" cy="0"/>
           </a:xfrm>
           <a:prstGeom prst="line">
             <a:avLst/>
@@ -3877,8 +3877,8 @@
         </p:nvCxnSpPr>
         <p:spPr>
           <a:xfrm>
-            <a:off x="699358" y="302697"/>
-            <a:ext cx="0" cy="94594"/>
+            <a:off x="948453" y="362606"/>
+            <a:ext cx="0" cy="141890"/>
           </a:xfrm>
           <a:prstGeom prst="line">
             <a:avLst/>
@@ -3912,8 +3912,8 @@
         </p:nvCxnSpPr>
         <p:spPr>
           <a:xfrm>
-            <a:off x="699358" y="302697"/>
-            <a:ext cx="63062" cy="0"/>
+            <a:off x="948453" y="362606"/>
+            <a:ext cx="94593" cy="0"/>
           </a:xfrm>
           <a:prstGeom prst="line">
             <a:avLst/>
@@ -3947,8 +3947,8 @@
         </p:nvCxnSpPr>
         <p:spPr>
           <a:xfrm>
-            <a:off x="762420" y="302697"/>
-            <a:ext cx="0" cy="44144"/>
+            <a:off x="1043046" y="362606"/>
+            <a:ext cx="0" cy="66216"/>
           </a:xfrm>
           <a:prstGeom prst="line">
             <a:avLst/>
@@ -3982,8 +3982,8 @@
         </p:nvCxnSpPr>
         <p:spPr>
           <a:xfrm flipH="1">
-            <a:off x="699358" y="346841"/>
-            <a:ext cx="63062" cy="0"/>
+            <a:off x="948453" y="428822"/>
+            <a:ext cx="94593" cy="0"/>
           </a:xfrm>
           <a:prstGeom prst="line">
             <a:avLst/>
@@ -4017,8 +4017,8 @@
         </p:nvCxnSpPr>
         <p:spPr>
           <a:xfrm>
-            <a:off x="724583" y="346841"/>
-            <a:ext cx="37837" cy="50450"/>
+            <a:off x="986290" y="428822"/>
+            <a:ext cx="56756" cy="75674"/>
           </a:xfrm>
           <a:prstGeom prst="line">
             <a:avLst/>
@@ -4052,8 +4052,8 @@
         </p:nvCxnSpPr>
         <p:spPr>
           <a:xfrm>
-            <a:off x="806563" y="302697"/>
-            <a:ext cx="0" cy="94594"/>
+            <a:off x="1109261" y="362606"/>
+            <a:ext cx="0" cy="141890"/>
           </a:xfrm>
           <a:prstGeom prst="line">
             <a:avLst/>
@@ -4087,8 +4087,8 @@
         </p:nvCxnSpPr>
         <p:spPr>
           <a:xfrm>
-            <a:off x="775032" y="302697"/>
-            <a:ext cx="63062" cy="0"/>
+            <a:off x="1061965" y="362606"/>
+            <a:ext cx="94593" cy="0"/>
           </a:xfrm>
           <a:prstGeom prst="line">
             <a:avLst/>
@@ -4122,8 +4122,8 @@
         </p:nvCxnSpPr>
         <p:spPr>
           <a:xfrm>
-            <a:off x="775032" y="397291"/>
-            <a:ext cx="63062" cy="0"/>
+            <a:off x="1061965" y="504496"/>
+            <a:ext cx="94593" cy="0"/>
           </a:xfrm>
           <a:prstGeom prst="line">
             <a:avLst/>
@@ -4157,8 +4157,8 @@
         </p:nvCxnSpPr>
         <p:spPr>
           <a:xfrm>
-            <a:off x="850707" y="302697"/>
-            <a:ext cx="0" cy="94594"/>
+            <a:off x="1175476" y="362606"/>
+            <a:ext cx="0" cy="141890"/>
           </a:xfrm>
           <a:prstGeom prst="line">
             <a:avLst/>
@@ -4192,8 +4192,8 @@
         </p:nvCxnSpPr>
         <p:spPr>
           <a:xfrm flipV="1">
-            <a:off x="850707" y="302697"/>
-            <a:ext cx="63062" cy="44144"/>
+            <a:off x="1175476" y="362606"/>
+            <a:ext cx="94594" cy="66216"/>
           </a:xfrm>
           <a:prstGeom prst="line">
             <a:avLst/>
@@ -4227,8 +4227,8 @@
         </p:nvCxnSpPr>
         <p:spPr>
           <a:xfrm>
-            <a:off x="850707" y="346841"/>
-            <a:ext cx="63062" cy="50450"/>
+            <a:off x="1175476" y="428822"/>
+            <a:ext cx="94594" cy="75674"/>
           </a:xfrm>
           <a:prstGeom prst="line">
             <a:avLst/>
@@ -5679,8 +5679,8 @@
         </p:nvCxnSpPr>
         <p:spPr>
           <a:xfrm>
-            <a:off x="201168" y="283779"/>
-            <a:ext cx="321616" cy="0"/>
+            <a:off x="201168" y="334228"/>
+            <a:ext cx="482424" cy="0"/>
           </a:xfrm>
           <a:prstGeom prst="line">
             <a:avLst/>
@@ -5714,8 +5714,8 @@
         </p:nvCxnSpPr>
         <p:spPr>
           <a:xfrm>
-            <a:off x="201168" y="409903"/>
-            <a:ext cx="321616" cy="0"/>
+            <a:off x="201168" y="523415"/>
+            <a:ext cx="482424" cy="0"/>
           </a:xfrm>
           <a:prstGeom prst="line">
             <a:avLst/>
@@ -5749,8 +5749,8 @@
         </p:nvCxnSpPr>
         <p:spPr>
           <a:xfrm>
-            <a:off x="201168" y="283779"/>
-            <a:ext cx="0" cy="126124"/>
+            <a:off x="201168" y="334228"/>
+            <a:ext cx="0" cy="189187"/>
           </a:xfrm>
           <a:prstGeom prst="line">
             <a:avLst/>
@@ -5784,8 +5784,8 @@
         </p:nvCxnSpPr>
         <p:spPr>
           <a:xfrm>
-            <a:off x="522784" y="283779"/>
-            <a:ext cx="0" cy="126124"/>
+            <a:off x="683592" y="334228"/>
+            <a:ext cx="0" cy="189187"/>
           </a:xfrm>
           <a:prstGeom prst="line">
             <a:avLst/>
@@ -5819,8 +5819,8 @@
         </p:nvCxnSpPr>
         <p:spPr>
           <a:xfrm>
-            <a:off x="220086" y="302697"/>
-            <a:ext cx="63062" cy="0"/>
+            <a:off x="229545" y="362606"/>
+            <a:ext cx="94594" cy="0"/>
           </a:xfrm>
           <a:prstGeom prst="line">
             <a:avLst/>
@@ -5854,8 +5854,8 @@
         </p:nvCxnSpPr>
         <p:spPr>
           <a:xfrm>
-            <a:off x="251617" y="302697"/>
-            <a:ext cx="0" cy="94594"/>
+            <a:off x="276842" y="362606"/>
+            <a:ext cx="0" cy="141890"/>
           </a:xfrm>
           <a:prstGeom prst="line">
             <a:avLst/>
@@ -5889,8 +5889,8 @@
         </p:nvCxnSpPr>
         <p:spPr>
           <a:xfrm flipH="1">
-            <a:off x="295761" y="302697"/>
-            <a:ext cx="63062" cy="0"/>
+            <a:off x="343057" y="362606"/>
+            <a:ext cx="94593" cy="0"/>
           </a:xfrm>
           <a:prstGeom prst="line">
             <a:avLst/>
@@ -5924,8 +5924,8 @@
         </p:nvCxnSpPr>
         <p:spPr>
           <a:xfrm>
-            <a:off x="295761" y="302697"/>
-            <a:ext cx="0" cy="94594"/>
+            <a:off x="343057" y="362606"/>
+            <a:ext cx="0" cy="141890"/>
           </a:xfrm>
           <a:prstGeom prst="line">
             <a:avLst/>
@@ -5959,8 +5959,8 @@
         </p:nvCxnSpPr>
         <p:spPr>
           <a:xfrm>
-            <a:off x="295761" y="397291"/>
-            <a:ext cx="63062" cy="0"/>
+            <a:off x="343057" y="504496"/>
+            <a:ext cx="94593" cy="0"/>
           </a:xfrm>
           <a:prstGeom prst="line">
             <a:avLst/>
@@ -5994,8 +5994,8 @@
         </p:nvCxnSpPr>
         <p:spPr>
           <a:xfrm>
-            <a:off x="295761" y="346841"/>
-            <a:ext cx="50449" cy="0"/>
+            <a:off x="343057" y="428822"/>
+            <a:ext cx="75675" cy="0"/>
           </a:xfrm>
           <a:prstGeom prst="line">
             <a:avLst/>
@@ -6029,8 +6029,8 @@
         </p:nvCxnSpPr>
         <p:spPr>
           <a:xfrm flipH="1">
-            <a:off x="371435" y="302697"/>
-            <a:ext cx="63062" cy="0"/>
+            <a:off x="456569" y="362606"/>
+            <a:ext cx="94593" cy="0"/>
           </a:xfrm>
           <a:prstGeom prst="line">
             <a:avLst/>
@@ -6064,8 +6064,8 @@
         </p:nvCxnSpPr>
         <p:spPr>
           <a:xfrm>
-            <a:off x="371435" y="302697"/>
-            <a:ext cx="0" cy="94594"/>
+            <a:off x="456569" y="362606"/>
+            <a:ext cx="0" cy="141890"/>
           </a:xfrm>
           <a:prstGeom prst="line">
             <a:avLst/>
@@ -6099,8 +6099,8 @@
         </p:nvCxnSpPr>
         <p:spPr>
           <a:xfrm>
-            <a:off x="371435" y="397291"/>
-            <a:ext cx="63062" cy="0"/>
+            <a:off x="456569" y="504496"/>
+            <a:ext cx="94593" cy="0"/>
           </a:xfrm>
           <a:prstGeom prst="line">
             <a:avLst/>
@@ -6134,8 +6134,8 @@
         </p:nvCxnSpPr>
         <p:spPr>
           <a:xfrm>
-            <a:off x="447110" y="302697"/>
-            <a:ext cx="0" cy="94594"/>
+            <a:off x="570081" y="362606"/>
+            <a:ext cx="0" cy="141890"/>
           </a:xfrm>
           <a:prstGeom prst="line">
             <a:avLst/>
@@ -6169,8 +6169,8 @@
         </p:nvCxnSpPr>
         <p:spPr>
           <a:xfrm>
-            <a:off x="510172" y="302697"/>
-            <a:ext cx="0" cy="94594"/>
+            <a:off x="664674" y="362606"/>
+            <a:ext cx="0" cy="141890"/>
           </a:xfrm>
           <a:prstGeom prst="line">
             <a:avLst/>
@@ -6204,8 +6204,8 @@
         </p:nvCxnSpPr>
         <p:spPr>
           <a:xfrm>
-            <a:off x="447110" y="346841"/>
-            <a:ext cx="63062" cy="0"/>
+            <a:off x="570081" y="428822"/>
+            <a:ext cx="94593" cy="0"/>
           </a:xfrm>
           <a:prstGeom prst="line">
             <a:avLst/>
@@ -6239,8 +6239,8 @@
         </p:nvCxnSpPr>
         <p:spPr>
           <a:xfrm flipV="1">
-            <a:off x="548009" y="302697"/>
-            <a:ext cx="31531" cy="94594"/>
+            <a:off x="721430" y="362606"/>
+            <a:ext cx="47296" cy="141890"/>
           </a:xfrm>
           <a:prstGeom prst="line">
             <a:avLst/>
@@ -6274,8 +6274,8 @@
         </p:nvCxnSpPr>
         <p:spPr>
           <a:xfrm>
-            <a:off x="579540" y="302697"/>
-            <a:ext cx="31531" cy="94594"/>
+            <a:off x="768726" y="362606"/>
+            <a:ext cx="47297" cy="141890"/>
           </a:xfrm>
           <a:prstGeom prst="line">
             <a:avLst/>
@@ -6309,8 +6309,8 @@
         </p:nvCxnSpPr>
         <p:spPr>
           <a:xfrm>
-            <a:off x="560621" y="353147"/>
-            <a:ext cx="37838" cy="0"/>
+            <a:off x="740348" y="438281"/>
+            <a:ext cx="56756" cy="0"/>
           </a:xfrm>
           <a:prstGeom prst="line">
             <a:avLst/>
@@ -6344,8 +6344,8 @@
         </p:nvCxnSpPr>
         <p:spPr>
           <a:xfrm flipH="1">
-            <a:off x="623683" y="302697"/>
-            <a:ext cx="63062" cy="0"/>
+            <a:off x="834941" y="362606"/>
+            <a:ext cx="94593" cy="0"/>
           </a:xfrm>
           <a:prstGeom prst="line">
             <a:avLst/>
@@ -6379,8 +6379,8 @@
         </p:nvCxnSpPr>
         <p:spPr>
           <a:xfrm>
-            <a:off x="623683" y="302697"/>
-            <a:ext cx="0" cy="94594"/>
+            <a:off x="834941" y="362606"/>
+            <a:ext cx="0" cy="141890"/>
           </a:xfrm>
           <a:prstGeom prst="line">
             <a:avLst/>
@@ -6414,8 +6414,8 @@
         </p:nvCxnSpPr>
         <p:spPr>
           <a:xfrm>
-            <a:off x="623683" y="346841"/>
-            <a:ext cx="50450" cy="0"/>
+            <a:off x="834941" y="428822"/>
+            <a:ext cx="75675" cy="0"/>
           </a:xfrm>
           <a:prstGeom prst="line">
             <a:avLst/>
@@ -6449,8 +6449,8 @@
         </p:nvCxnSpPr>
         <p:spPr>
           <a:xfrm>
-            <a:off x="699358" y="302697"/>
-            <a:ext cx="0" cy="94594"/>
+            <a:off x="948453" y="362606"/>
+            <a:ext cx="0" cy="141890"/>
           </a:xfrm>
           <a:prstGeom prst="line">
             <a:avLst/>
@@ -6484,8 +6484,8 @@
         </p:nvCxnSpPr>
         <p:spPr>
           <a:xfrm>
-            <a:off x="699358" y="302697"/>
-            <a:ext cx="63062" cy="0"/>
+            <a:off x="948453" y="362606"/>
+            <a:ext cx="94593" cy="0"/>
           </a:xfrm>
           <a:prstGeom prst="line">
             <a:avLst/>
@@ -6519,8 +6519,8 @@
         </p:nvCxnSpPr>
         <p:spPr>
           <a:xfrm>
-            <a:off x="762420" y="302697"/>
-            <a:ext cx="0" cy="44144"/>
+            <a:off x="1043046" y="362606"/>
+            <a:ext cx="0" cy="66216"/>
           </a:xfrm>
           <a:prstGeom prst="line">
             <a:avLst/>
@@ -6554,8 +6554,8 @@
         </p:nvCxnSpPr>
         <p:spPr>
           <a:xfrm flipH="1">
-            <a:off x="699358" y="346841"/>
-            <a:ext cx="63062" cy="0"/>
+            <a:off x="948453" y="428822"/>
+            <a:ext cx="94593" cy="0"/>
           </a:xfrm>
           <a:prstGeom prst="line">
             <a:avLst/>
@@ -6589,8 +6589,8 @@
         </p:nvCxnSpPr>
         <p:spPr>
           <a:xfrm>
-            <a:off x="724583" y="346841"/>
-            <a:ext cx="37837" cy="50450"/>
+            <a:off x="986290" y="428822"/>
+            <a:ext cx="56756" cy="75674"/>
           </a:xfrm>
           <a:prstGeom prst="line">
             <a:avLst/>
@@ -6624,8 +6624,8 @@
         </p:nvCxnSpPr>
         <p:spPr>
           <a:xfrm>
-            <a:off x="806563" y="302697"/>
-            <a:ext cx="0" cy="94594"/>
+            <a:off x="1109261" y="362606"/>
+            <a:ext cx="0" cy="141890"/>
           </a:xfrm>
           <a:prstGeom prst="line">
             <a:avLst/>
@@ -6659,8 +6659,8 @@
         </p:nvCxnSpPr>
         <p:spPr>
           <a:xfrm>
-            <a:off x="775032" y="302697"/>
-            <a:ext cx="63062" cy="0"/>
+            <a:off x="1061965" y="362606"/>
+            <a:ext cx="94593" cy="0"/>
           </a:xfrm>
           <a:prstGeom prst="line">
             <a:avLst/>
@@ -6694,8 +6694,8 @@
         </p:nvCxnSpPr>
         <p:spPr>
           <a:xfrm>
-            <a:off x="775032" y="397291"/>
-            <a:ext cx="63062" cy="0"/>
+            <a:off x="1061965" y="504496"/>
+            <a:ext cx="94593" cy="0"/>
           </a:xfrm>
           <a:prstGeom prst="line">
             <a:avLst/>
@@ -6729,8 +6729,8 @@
         </p:nvCxnSpPr>
         <p:spPr>
           <a:xfrm>
-            <a:off x="850707" y="302697"/>
-            <a:ext cx="0" cy="94594"/>
+            <a:off x="1175476" y="362606"/>
+            <a:ext cx="0" cy="141890"/>
           </a:xfrm>
           <a:prstGeom prst="line">
             <a:avLst/>
@@ -6764,8 +6764,8 @@
         </p:nvCxnSpPr>
         <p:spPr>
           <a:xfrm flipV="1">
-            <a:off x="850707" y="302697"/>
-            <a:ext cx="63062" cy="44144"/>
+            <a:off x="1175476" y="362606"/>
+            <a:ext cx="94594" cy="66216"/>
           </a:xfrm>
           <a:prstGeom prst="line">
             <a:avLst/>
@@ -6799,8 +6799,8 @@
         </p:nvCxnSpPr>
         <p:spPr>
           <a:xfrm>
-            <a:off x="850707" y="346841"/>
-            <a:ext cx="63062" cy="50450"/>
+            <a:off x="1175476" y="428822"/>
+            <a:ext cx="94594" cy="75674"/>
           </a:xfrm>
           <a:prstGeom prst="line">
             <a:avLst/>

</xml_diff>